<commit_message>
Íconos de la presentación como SVG editables en PowerPoint
Co-Authored-By: Claude Opus 5.5 <noreply@anthropic.com>
Claude-Session: https://claude.ai/code/session_01SpvEraPJH8MhfMVsx7uRJu
</commit_message>
<xml_diff>
--- a/presentaciones/Presentacion_Comite_F-INV-004_Testigos_de_Jehova_cirugia_cardiaca.pptx
+++ b/presentaciones/Presentacion_Comite_F-INV-004_Testigos_de_Jehova_cirugia_cardiaca.pptx
@@ -23656,14 +23656,20 @@
       </p:sp>
       <p:pic>
         <p:nvPicPr>
-          <p:cNvPr id="77" name="Imagen 77" descr="coins"/>
+          <p:cNvPr id="77" name="Icono coins 77" descr="coins"/>
           <p:cNvPicPr>
             <a:picLocks noChangeAspect="1"/>
           </p:cNvPicPr>
           <p:nvPr/>
         </p:nvPicPr>
         <p:blipFill>
-          <a:blip r:embed="rId3"/>
+          <a:blip r:embed="rId3">
+            <a:extLst>
+              <a:ext uri="{96DAC541-7B7A-43D3-8B79-37D633B846F1}">
+                <asvg:svgBlip xmlns:asvg="http://schemas.microsoft.com/office/drawing/2016/SVG/main" r:embed="rId4"/>
+              </a:ext>
+            </a:extLst>
+          </a:blip>
           <a:stretch>
             <a:fillRect/>
           </a:stretch>
@@ -24202,14 +24208,20 @@
       </p:sp>
       <p:pic>
         <p:nvPicPr>
-          <p:cNvPr id="7" name="Imagen 7" descr="microscope"/>
+          <p:cNvPr id="7" name="Icono microscope 7" descr="microscope"/>
           <p:cNvPicPr>
             <a:picLocks noChangeAspect="1"/>
           </p:cNvPicPr>
           <p:nvPr/>
         </p:nvPicPr>
         <p:blipFill>
-          <a:blip r:embed="rId3"/>
+          <a:blip r:embed="rId3">
+            <a:extLst>
+              <a:ext uri="{96DAC541-7B7A-43D3-8B79-37D633B846F1}">
+                <asvg:svgBlip xmlns:asvg="http://schemas.microsoft.com/office/drawing/2016/SVG/main" r:embed="rId4"/>
+              </a:ext>
+            </a:extLst>
+          </a:blip>
           <a:stretch>
             <a:fillRect/>
           </a:stretch>
@@ -24419,14 +24431,20 @@
       </p:sp>
       <p:pic>
         <p:nvPicPr>
-          <p:cNvPr id="12" name="Imagen 12" descr="hospital"/>
+          <p:cNvPr id="12" name="Icono hospital 12" descr="hospital"/>
           <p:cNvPicPr>
             <a:picLocks noChangeAspect="1"/>
           </p:cNvPicPr>
           <p:nvPr/>
         </p:nvPicPr>
         <p:blipFill>
-          <a:blip r:embed="rId4"/>
+          <a:blip r:embed="rId5">
+            <a:extLst>
+              <a:ext uri="{96DAC541-7B7A-43D3-8B79-37D633B846F1}">
+                <asvg:svgBlip xmlns:asvg="http://schemas.microsoft.com/office/drawing/2016/SVG/main" r:embed="rId6"/>
+              </a:ext>
+            </a:extLst>
+          </a:blip>
           <a:stretch>
             <a:fillRect/>
           </a:stretch>
@@ -24636,14 +24654,20 @@
       </p:sp>
       <p:pic>
         <p:nvPicPr>
-          <p:cNvPr id="17" name="Imagen 17" descr="handmed"/>
+          <p:cNvPr id="17" name="Icono handmed 17" descr="handmed"/>
           <p:cNvPicPr>
             <a:picLocks noChangeAspect="1"/>
           </p:cNvPicPr>
           <p:nvPr/>
         </p:nvPicPr>
         <p:blipFill>
-          <a:blip r:embed="rId5"/>
+          <a:blip r:embed="rId7">
+            <a:extLst>
+              <a:ext uri="{96DAC541-7B7A-43D3-8B79-37D633B846F1}">
+                <asvg:svgBlip xmlns:asvg="http://schemas.microsoft.com/office/drawing/2016/SVG/main" r:embed="rId8"/>
+              </a:ext>
+            </a:extLst>
+          </a:blip>
           <a:stretch>
             <a:fillRect/>
           </a:stretch>
@@ -24862,14 +24886,20 @@
       </p:sp>
       <p:pic>
         <p:nvPicPr>
-          <p:cNvPr id="22" name="Imagen 22" descr="news"/>
+          <p:cNvPr id="22" name="Icono news 22" descr="news"/>
           <p:cNvPicPr>
             <a:picLocks noChangeAspect="1"/>
           </p:cNvPicPr>
           <p:nvPr/>
         </p:nvPicPr>
         <p:blipFill>
-          <a:blip r:embed="rId6"/>
+          <a:blip r:embed="rId9">
+            <a:extLst>
+              <a:ext uri="{96DAC541-7B7A-43D3-8B79-37D633B846F1}">
+                <asvg:svgBlip xmlns:asvg="http://schemas.microsoft.com/office/drawing/2016/SVG/main" r:embed="rId10"/>
+              </a:ext>
+            </a:extLst>
+          </a:blip>
           <a:stretch>
             <a:fillRect/>
           </a:stretch>
@@ -25132,14 +25162,20 @@
       </p:sp>
       <p:pic>
         <p:nvPicPr>
-          <p:cNvPr id="27" name="Imagen 27" descr="grad"/>
+          <p:cNvPr id="27" name="Icono grad 27" descr="grad"/>
           <p:cNvPicPr>
             <a:picLocks noChangeAspect="1"/>
           </p:cNvPicPr>
           <p:nvPr/>
         </p:nvPicPr>
         <p:blipFill>
-          <a:blip r:embed="rId7"/>
+          <a:blip r:embed="rId11">
+            <a:extLst>
+              <a:ext uri="{96DAC541-7B7A-43D3-8B79-37D633B846F1}">
+                <asvg:svgBlip xmlns:asvg="http://schemas.microsoft.com/office/drawing/2016/SVG/main" r:embed="rId12"/>
+              </a:ext>
+            </a:extLst>
+          </a:blip>
           <a:stretch>
             <a:fillRect/>
           </a:stretch>
@@ -25393,14 +25429,20 @@
       </p:sp>
       <p:pic>
         <p:nvPicPr>
-          <p:cNvPr id="32" name="Imagen 32" descr="bullhorn"/>
+          <p:cNvPr id="32" name="Icono bullhorn 32" descr="bullhorn"/>
           <p:cNvPicPr>
             <a:picLocks noChangeAspect="1"/>
           </p:cNvPicPr>
           <p:nvPr/>
         </p:nvPicPr>
         <p:blipFill>
-          <a:blip r:embed="rId8"/>
+          <a:blip r:embed="rId13">
+            <a:extLst>
+              <a:ext uri="{96DAC541-7B7A-43D3-8B79-37D633B846F1}">
+                <asvg:svgBlip xmlns:asvg="http://schemas.microsoft.com/office/drawing/2016/SVG/main" r:embed="rId14"/>
+              </a:ext>
+            </a:extLst>
+          </a:blip>
           <a:stretch>
             <a:fillRect/>
           </a:stretch>
@@ -25845,14 +25887,20 @@
       </p:sp>
       <p:pic>
         <p:nvPicPr>
-          <p:cNvPr id="7" name="Imagen 7" descr="shield"/>
+          <p:cNvPr id="7" name="Icono shield 7" descr="shield"/>
           <p:cNvPicPr>
             <a:picLocks noChangeAspect="1"/>
           </p:cNvPicPr>
           <p:nvPr/>
         </p:nvPicPr>
         <p:blipFill>
-          <a:blip r:embed="rId3"/>
+          <a:blip r:embed="rId3">
+            <a:extLst>
+              <a:ext uri="{96DAC541-7B7A-43D3-8B79-37D633B846F1}">
+                <asvg:svgBlip xmlns:asvg="http://schemas.microsoft.com/office/drawing/2016/SVG/main" r:embed="rId4"/>
+              </a:ext>
+            </a:extLst>
+          </a:blip>
           <a:stretch>
             <a:fillRect/>
           </a:stretch>
@@ -26132,14 +26180,20 @@
       </p:sp>
       <p:pic>
         <p:nvPicPr>
-          <p:cNvPr id="13" name="Imagen 13" descr="gavel"/>
+          <p:cNvPr id="13" name="Icono gavel 13" descr="gavel"/>
           <p:cNvPicPr>
             <a:picLocks noChangeAspect="1"/>
           </p:cNvPicPr>
           <p:nvPr/>
         </p:nvPicPr>
         <p:blipFill>
-          <a:blip r:embed="rId4"/>
+          <a:blip r:embed="rId5">
+            <a:extLst>
+              <a:ext uri="{96DAC541-7B7A-43D3-8B79-37D633B846F1}">
+                <asvg:svgBlip xmlns:asvg="http://schemas.microsoft.com/office/drawing/2016/SVG/main" r:embed="rId6"/>
+              </a:ext>
+            </a:extLst>
+          </a:blip>
           <a:stretch>
             <a:fillRect/>
           </a:stretch>
@@ -26351,14 +26405,20 @@
       </p:sp>
       <p:pic>
         <p:nvPicPr>
-          <p:cNvPr id="18" name="Imagen 18" descr="pen"/>
+          <p:cNvPr id="18" name="Icono pen 18" descr="pen"/>
           <p:cNvPicPr>
             <a:picLocks noChangeAspect="1"/>
           </p:cNvPicPr>
           <p:nvPr/>
         </p:nvPicPr>
         <p:blipFill>
-          <a:blip r:embed="rId5"/>
+          <a:blip r:embed="rId7">
+            <a:extLst>
+              <a:ext uri="{96DAC541-7B7A-43D3-8B79-37D633B846F1}">
+                <asvg:svgBlip xmlns:asvg="http://schemas.microsoft.com/office/drawing/2016/SVG/main" r:embed="rId8"/>
+              </a:ext>
+            </a:extLst>
+          </a:blip>
           <a:stretch>
             <a:fillRect/>
           </a:stretch>
@@ -26570,14 +26630,20 @@
       </p:sp>
       <p:pic>
         <p:nvPicPr>
-          <p:cNvPr id="23" name="Imagen 23" descr="lock"/>
+          <p:cNvPr id="23" name="Icono lock 23" descr="lock"/>
           <p:cNvPicPr>
             <a:picLocks noChangeAspect="1"/>
           </p:cNvPicPr>
           <p:nvPr/>
         </p:nvPicPr>
         <p:blipFill>
-          <a:blip r:embed="rId6"/>
+          <a:blip r:embed="rId9">
+            <a:extLst>
+              <a:ext uri="{96DAC541-7B7A-43D3-8B79-37D633B846F1}">
+                <asvg:svgBlip xmlns:asvg="http://schemas.microsoft.com/office/drawing/2016/SVG/main" r:embed="rId10"/>
+              </a:ext>
+            </a:extLst>
+          </a:blip>
           <a:stretch>
             <a:fillRect/>
           </a:stretch>
@@ -26787,14 +26853,20 @@
       </p:sp>
       <p:pic>
         <p:nvPicPr>
-          <p:cNvPr id="28" name="Imagen 28" descr="handshake"/>
+          <p:cNvPr id="28" name="Icono handshake 28" descr="handshake"/>
           <p:cNvPicPr>
             <a:picLocks noChangeAspect="1"/>
           </p:cNvPicPr>
           <p:nvPr/>
         </p:nvPicPr>
         <p:blipFill>
-          <a:blip r:embed="rId7"/>
+          <a:blip r:embed="rId11">
+            <a:extLst>
+              <a:ext uri="{96DAC541-7B7A-43D3-8B79-37D633B846F1}">
+                <asvg:svgBlip xmlns:asvg="http://schemas.microsoft.com/office/drawing/2016/SVG/main" r:embed="rId12"/>
+              </a:ext>
+            </a:extLst>
+          </a:blip>
           <a:stretch>
             <a:fillRect/>
           </a:stretch>
@@ -27082,14 +27154,20 @@
       </p:sp>
       <p:pic>
         <p:nvPicPr>
-          <p:cNvPr id="7" name="Imagen 7" descr="sigma"/>
+          <p:cNvPr id="7" name="Icono sigma 7" descr="sigma"/>
           <p:cNvPicPr>
             <a:picLocks noChangeAspect="1"/>
           </p:cNvPicPr>
           <p:nvPr/>
         </p:nvPicPr>
         <p:blipFill>
-          <a:blip r:embed="rId3"/>
+          <a:blip r:embed="rId3">
+            <a:extLst>
+              <a:ext uri="{96DAC541-7B7A-43D3-8B79-37D633B846F1}">
+                <asvg:svgBlip xmlns:asvg="http://schemas.microsoft.com/office/drawing/2016/SVG/main" r:embed="rId4"/>
+              </a:ext>
+            </a:extLst>
+          </a:blip>
           <a:stretch>
             <a:fillRect/>
           </a:stretch>
@@ -27385,14 +27463,20 @@
       </p:sp>
       <p:pic>
         <p:nvPicPr>
-          <p:cNvPr id="12" name="Imagen 12" descr="chart"/>
+          <p:cNvPr id="12" name="Icono chart 12" descr="chart"/>
           <p:cNvPicPr>
             <a:picLocks noChangeAspect="1"/>
           </p:cNvPicPr>
           <p:nvPr/>
         </p:nvPicPr>
         <p:blipFill>
-          <a:blip r:embed="rId4"/>
+          <a:blip r:embed="rId5">
+            <a:extLst>
+              <a:ext uri="{96DAC541-7B7A-43D3-8B79-37D633B846F1}">
+                <asvg:svgBlip xmlns:asvg="http://schemas.microsoft.com/office/drawing/2016/SVG/main" r:embed="rId6"/>
+              </a:ext>
+            </a:extLst>
+          </a:blip>
           <a:stretch>
             <a:fillRect/>
           </a:stretch>
@@ -27679,14 +27763,20 @@
       </p:sp>
       <p:pic>
         <p:nvPicPr>
-          <p:cNvPr id="17" name="Imagen 17" descr="filter"/>
+          <p:cNvPr id="17" name="Icono filter 17" descr="filter"/>
           <p:cNvPicPr>
             <a:picLocks noChangeAspect="1"/>
           </p:cNvPicPr>
           <p:nvPr/>
         </p:nvPicPr>
         <p:blipFill>
-          <a:blip r:embed="rId5"/>
+          <a:blip r:embed="rId7">
+            <a:extLst>
+              <a:ext uri="{96DAC541-7B7A-43D3-8B79-37D633B846F1}">
+                <asvg:svgBlip xmlns:asvg="http://schemas.microsoft.com/office/drawing/2016/SVG/main" r:embed="rId8"/>
+              </a:ext>
+            </a:extLst>
+          </a:blip>
           <a:stretch>
             <a:fillRect/>
           </a:stretch>
@@ -28478,14 +28568,20 @@
       </p:sp>
       <p:pic>
         <p:nvPicPr>
-          <p:cNvPr id="8" name="Imagen 8" descr="clipboard"/>
+          <p:cNvPr id="8" name="Icono clipboard 8" descr="clipboard"/>
           <p:cNvPicPr>
             <a:picLocks noChangeAspect="1"/>
           </p:cNvPicPr>
           <p:nvPr/>
         </p:nvPicPr>
         <p:blipFill>
-          <a:blip r:embed="rId3"/>
+          <a:blip r:embed="rId3">
+            <a:extLst>
+              <a:ext uri="{96DAC541-7B7A-43D3-8B79-37D633B846F1}">
+                <asvg:svgBlip xmlns:asvg="http://schemas.microsoft.com/office/drawing/2016/SVG/main" r:embed="rId4"/>
+              </a:ext>
+            </a:extLst>
+          </a:blip>
           <a:stretch>
             <a:fillRect/>
           </a:stretch>
@@ -28598,14 +28694,20 @@
       </p:sp>
       <p:pic>
         <p:nvPicPr>
-          <p:cNvPr id="11" name="Imagen 11" descr="search"/>
+          <p:cNvPr id="11" name="Icono search 11" descr="search"/>
           <p:cNvPicPr>
             <a:picLocks noChangeAspect="1"/>
           </p:cNvPicPr>
           <p:nvPr/>
         </p:nvPicPr>
         <p:blipFill>
-          <a:blip r:embed="rId4"/>
+          <a:blip r:embed="rId5">
+            <a:extLst>
+              <a:ext uri="{96DAC541-7B7A-43D3-8B79-37D633B846F1}">
+                <asvg:svgBlip xmlns:asvg="http://schemas.microsoft.com/office/drawing/2016/SVG/main" r:embed="rId6"/>
+              </a:ext>
+            </a:extLst>
+          </a:blip>
           <a:stretch>
             <a:fillRect/>
           </a:stretch>
@@ -28718,14 +28820,20 @@
       </p:sp>
       <p:pic>
         <p:nvPicPr>
-          <p:cNvPr id="14" name="Imagen 14" descr="filemed"/>
+          <p:cNvPr id="14" name="Icono filemed 14" descr="filemed"/>
           <p:cNvPicPr>
             <a:picLocks noChangeAspect="1"/>
           </p:cNvPicPr>
           <p:nvPr/>
         </p:nvPicPr>
         <p:blipFill>
-          <a:blip r:embed="rId5"/>
+          <a:blip r:embed="rId7">
+            <a:extLst>
+              <a:ext uri="{96DAC541-7B7A-43D3-8B79-37D633B846F1}">
+                <asvg:svgBlip xmlns:asvg="http://schemas.microsoft.com/office/drawing/2016/SVG/main" r:embed="rId8"/>
+              </a:ext>
+            </a:extLst>
+          </a:blip>
           <a:stretch>
             <a:fillRect/>
           </a:stretch>
@@ -28838,14 +28946,20 @@
       </p:sp>
       <p:pic>
         <p:nvPicPr>
-          <p:cNvPr id="17" name="Imagen 17" descr="dropslash"/>
+          <p:cNvPr id="17" name="Icono dropslash 17" descr="dropslash"/>
           <p:cNvPicPr>
             <a:picLocks noChangeAspect="1"/>
           </p:cNvPicPr>
           <p:nvPr/>
         </p:nvPicPr>
         <p:blipFill>
-          <a:blip r:embed="rId6"/>
+          <a:blip r:embed="rId9">
+            <a:extLst>
+              <a:ext uri="{96DAC541-7B7A-43D3-8B79-37D633B846F1}">
+                <asvg:svgBlip xmlns:asvg="http://schemas.microsoft.com/office/drawing/2016/SVG/main" r:embed="rId10"/>
+              </a:ext>
+            </a:extLst>
+          </a:blip>
           <a:stretch>
             <a:fillRect/>
           </a:stretch>
@@ -29054,14 +29168,20 @@
       </p:sp>
       <p:pic>
         <p:nvPicPr>
-          <p:cNvPr id="22" name="Imagen 22" descr="usercheck"/>
+          <p:cNvPr id="22" name="Icono usercheck 22" descr="usercheck"/>
           <p:cNvPicPr>
             <a:picLocks noChangeAspect="1"/>
           </p:cNvPicPr>
           <p:nvPr/>
         </p:nvPicPr>
         <p:blipFill>
-          <a:blip r:embed="rId7"/>
+          <a:blip r:embed="rId11">
+            <a:extLst>
+              <a:ext uri="{96DAC541-7B7A-43D3-8B79-37D633B846F1}">
+                <asvg:svgBlip xmlns:asvg="http://schemas.microsoft.com/office/drawing/2016/SVG/main" r:embed="rId12"/>
+              </a:ext>
+            </a:extLst>
+          </a:blip>
           <a:stretch>
             <a:fillRect/>
           </a:stretch>
@@ -29319,14 +29439,20 @@
       </p:sp>
       <p:pic>
         <p:nvPicPr>
-          <p:cNvPr id="28" name="Imagen 28" descr="laptop"/>
+          <p:cNvPr id="28" name="Icono laptop 28" descr="laptop"/>
           <p:cNvPicPr>
             <a:picLocks noChangeAspect="1"/>
           </p:cNvPicPr>
           <p:nvPr/>
         </p:nvPicPr>
         <p:blipFill>
-          <a:blip r:embed="rId8"/>
+          <a:blip r:embed="rId13">
+            <a:extLst>
+              <a:ext uri="{96DAC541-7B7A-43D3-8B79-37D633B846F1}">
+                <asvg:svgBlip xmlns:asvg="http://schemas.microsoft.com/office/drawing/2016/SVG/main" r:embed="rId14"/>
+              </a:ext>
+            </a:extLst>
+          </a:blip>
           <a:stretch>
             <a:fillRect/>
           </a:stretch>
@@ -29584,14 +29710,20 @@
       </p:sp>
       <p:pic>
         <p:nvPicPr>
-          <p:cNvPr id="34" name="Imagen 34" descr="list"/>
+          <p:cNvPr id="34" name="Icono list 34" descr="list"/>
           <p:cNvPicPr>
             <a:picLocks noChangeAspect="1"/>
           </p:cNvPicPr>
           <p:nvPr/>
         </p:nvPicPr>
         <p:blipFill>
-          <a:blip r:embed="rId9"/>
+          <a:blip r:embed="rId15">
+            <a:extLst>
+              <a:ext uri="{96DAC541-7B7A-43D3-8B79-37D633B846F1}">
+                <asvg:svgBlip xmlns:asvg="http://schemas.microsoft.com/office/drawing/2016/SVG/main" r:embed="rId16"/>
+              </a:ext>
+            </a:extLst>
+          </a:blip>
           <a:stretch>
             <a:fillRect/>
           </a:stretch>
@@ -29803,14 +29935,20 @@
       </p:sp>
       <p:pic>
         <p:nvPicPr>
-          <p:cNvPr id="39" name="Imagen 39" descr="userlock"/>
+          <p:cNvPr id="39" name="Icono userlock 39" descr="userlock"/>
           <p:cNvPicPr>
             <a:picLocks noChangeAspect="1"/>
           </p:cNvPicPr>
           <p:nvPr/>
         </p:nvPicPr>
         <p:blipFill>
-          <a:blip r:embed="rId10"/>
+          <a:blip r:embed="rId17">
+            <a:extLst>
+              <a:ext uri="{96DAC541-7B7A-43D3-8B79-37D633B846F1}">
+                <asvg:svgBlip xmlns:asvg="http://schemas.microsoft.com/office/drawing/2016/SVG/main" r:embed="rId18"/>
+              </a:ext>
+            </a:extLst>
+          </a:blip>
           <a:stretch>
             <a:fillRect/>
           </a:stretch>
@@ -30019,14 +30157,20 @@
       </p:sp>
       <p:pic>
         <p:nvPicPr>
-          <p:cNvPr id="44" name="Imagen 44" descr="calendar"/>
+          <p:cNvPr id="44" name="Icono calendar 44" descr="calendar"/>
           <p:cNvPicPr>
             <a:picLocks noChangeAspect="1"/>
           </p:cNvPicPr>
           <p:nvPr/>
         </p:nvPicPr>
         <p:blipFill>
-          <a:blip r:embed="rId11"/>
+          <a:blip r:embed="rId19">
+            <a:extLst>
+              <a:ext uri="{96DAC541-7B7A-43D3-8B79-37D633B846F1}">
+                <asvg:svgBlip xmlns:asvg="http://schemas.microsoft.com/office/drawing/2016/SVG/main" r:embed="rId20"/>
+              </a:ext>
+            </a:extLst>
+          </a:blip>
           <a:stretch>
             <a:fillRect/>
           </a:stretch>
@@ -30235,14 +30379,20 @@
       </p:sp>
       <p:pic>
         <p:nvPicPr>
-          <p:cNvPr id="49" name="Imagen 49" descr="database"/>
+          <p:cNvPr id="49" name="Icono database 49" descr="database"/>
           <p:cNvPicPr>
             <a:picLocks noChangeAspect="1"/>
           </p:cNvPicPr>
           <p:nvPr/>
         </p:nvPicPr>
         <p:blipFill>
-          <a:blip r:embed="rId12"/>
+          <a:blip r:embed="rId21">
+            <a:extLst>
+              <a:ext uri="{96DAC541-7B7A-43D3-8B79-37D633B846F1}">
+                <asvg:svgBlip xmlns:asvg="http://schemas.microsoft.com/office/drawing/2016/SVG/main" r:embed="rId22"/>
+              </a:ext>
+            </a:extLst>
+          </a:blip>
           <a:stretch>
             <a:fillRect/>
           </a:stretch>
@@ -30573,14 +30723,20 @@
       </p:sp>
       <p:pic>
         <p:nvPicPr>
-          <p:cNvPr id="8" name="Imagen 8" descr="heartcrack"/>
+          <p:cNvPr id="8" name="Icono heartcrack 8" descr="heartcrack"/>
           <p:cNvPicPr>
             <a:picLocks noChangeAspect="1"/>
           </p:cNvPicPr>
           <p:nvPr/>
         </p:nvPicPr>
         <p:blipFill>
-          <a:blip r:embed="rId3"/>
+          <a:blip r:embed="rId3">
+            <a:extLst>
+              <a:ext uri="{96DAC541-7B7A-43D3-8B79-37D633B846F1}">
+                <asvg:svgBlip xmlns:asvg="http://schemas.microsoft.com/office/drawing/2016/SVG/main" r:embed="rId4"/>
+              </a:ext>
+            </a:extLst>
+          </a:blip>
           <a:stretch>
             <a:fillRect/>
           </a:stretch>
@@ -30789,14 +30945,20 @@
       </p:sp>
       <p:pic>
         <p:nvPicPr>
-          <p:cNvPr id="13" name="Imagen 13" descr="brain"/>
+          <p:cNvPr id="13" name="Icono brain 13" descr="brain"/>
           <p:cNvPicPr>
             <a:picLocks noChangeAspect="1"/>
           </p:cNvPicPr>
           <p:nvPr/>
         </p:nvPicPr>
         <p:blipFill>
-          <a:blip r:embed="rId4"/>
+          <a:blip r:embed="rId5">
+            <a:extLst>
+              <a:ext uri="{96DAC541-7B7A-43D3-8B79-37D633B846F1}">
+                <asvg:svgBlip xmlns:asvg="http://schemas.microsoft.com/office/drawing/2016/SVG/main" r:embed="rId6"/>
+              </a:ext>
+            </a:extLst>
+          </a:blip>
           <a:stretch>
             <a:fillRect/>
           </a:stretch>
@@ -31003,14 +31165,20 @@
       </p:sp>
       <p:pic>
         <p:nvPicPr>
-          <p:cNvPr id="18" name="Imagen 18" descr="heartpulse"/>
+          <p:cNvPr id="18" name="Icono heartpulse 18" descr="heartpulse"/>
           <p:cNvPicPr>
             <a:picLocks noChangeAspect="1"/>
           </p:cNvPicPr>
           <p:nvPr/>
         </p:nvPicPr>
         <p:blipFill>
-          <a:blip r:embed="rId5"/>
+          <a:blip r:embed="rId7">
+            <a:extLst>
+              <a:ext uri="{96DAC541-7B7A-43D3-8B79-37D633B846F1}">
+                <asvg:svgBlip xmlns:asvg="http://schemas.microsoft.com/office/drawing/2016/SVG/main" r:embed="rId8"/>
+              </a:ext>
+            </a:extLst>
+          </a:blip>
           <a:stretch>
             <a:fillRect/>
           </a:stretch>
@@ -31227,14 +31395,20 @@
       </p:sp>
       <p:pic>
         <p:nvPicPr>
-          <p:cNvPr id="23" name="Imagen 23" descr="kidney"/>
+          <p:cNvPr id="23" name="Icono kidney 23" descr="kidney"/>
           <p:cNvPicPr>
             <a:picLocks noChangeAspect="1"/>
           </p:cNvPicPr>
           <p:nvPr/>
         </p:nvPicPr>
         <p:blipFill>
-          <a:blip r:embed="rId6"/>
+          <a:blip r:embed="rId9">
+            <a:extLst>
+              <a:ext uri="{96DAC541-7B7A-43D3-8B79-37D633B846F1}">
+                <asvg:svgBlip xmlns:asvg="http://schemas.microsoft.com/office/drawing/2016/SVG/main" r:embed="rId10"/>
+              </a:ext>
+            </a:extLst>
+          </a:blip>
           <a:stretch>
             <a:fillRect/>
           </a:stretch>
@@ -31451,14 +31625,20 @@
       </p:sp>
       <p:pic>
         <p:nvPicPr>
-          <p:cNvPr id="28" name="Imagen 28" descr="lungs"/>
+          <p:cNvPr id="28" name="Icono lungs 28" descr="lungs"/>
           <p:cNvPicPr>
             <a:picLocks noChangeAspect="1"/>
           </p:cNvPicPr>
           <p:nvPr/>
         </p:nvPicPr>
         <p:blipFill>
-          <a:blip r:embed="rId7"/>
+          <a:blip r:embed="rId11">
+            <a:extLst>
+              <a:ext uri="{96DAC541-7B7A-43D3-8B79-37D633B846F1}">
+                <asvg:svgBlip xmlns:asvg="http://schemas.microsoft.com/office/drawing/2016/SVG/main" r:embed="rId12"/>
+              </a:ext>
+            </a:extLst>
+          </a:blip>
           <a:stretch>
             <a:fillRect/>
           </a:stretch>
@@ -31665,14 +31845,20 @@
       </p:sp>
       <p:pic>
         <p:nvPicPr>
-          <p:cNvPr id="33" name="Imagen 33" descr="virus"/>
+          <p:cNvPr id="33" name="Icono virus 33" descr="virus"/>
           <p:cNvPicPr>
             <a:picLocks noChangeAspect="1"/>
           </p:cNvPicPr>
           <p:nvPr/>
         </p:nvPicPr>
         <p:blipFill>
-          <a:blip r:embed="rId8"/>
+          <a:blip r:embed="rId13">
+            <a:extLst>
+              <a:ext uri="{96DAC541-7B7A-43D3-8B79-37D633B846F1}">
+                <asvg:svgBlip xmlns:asvg="http://schemas.microsoft.com/office/drawing/2016/SVG/main" r:embed="rId14"/>
+              </a:ext>
+            </a:extLst>
+          </a:blip>
           <a:stretch>
             <a:fillRect/>
           </a:stretch>
@@ -31889,14 +32075,20 @@
       </p:sp>
       <p:pic>
         <p:nvPicPr>
-          <p:cNvPr id="38" name="Imagen 38" descr="doctor"/>
+          <p:cNvPr id="38" name="Icono doctor 38" descr="doctor"/>
           <p:cNvPicPr>
             <a:picLocks noChangeAspect="1"/>
           </p:cNvPicPr>
           <p:nvPr/>
         </p:nvPicPr>
         <p:blipFill>
-          <a:blip r:embed="rId9"/>
+          <a:blip r:embed="rId15">
+            <a:extLst>
+              <a:ext uri="{96DAC541-7B7A-43D3-8B79-37D633B846F1}">
+                <asvg:svgBlip xmlns:asvg="http://schemas.microsoft.com/office/drawing/2016/SVG/main" r:embed="rId16"/>
+              </a:ext>
+            </a:extLst>
+          </a:blip>
           <a:stretch>
             <a:fillRect/>
           </a:stretch>
@@ -32529,14 +32721,20 @@
       </p:sp>
       <p:pic>
         <p:nvPicPr>
-          <p:cNvPr id="51" name="Imagen 51" descr="droplet"/>
+          <p:cNvPr id="51" name="Icono droplet 51" descr="droplet"/>
           <p:cNvPicPr>
             <a:picLocks noChangeAspect="1"/>
           </p:cNvPicPr>
           <p:nvPr/>
         </p:nvPicPr>
         <p:blipFill>
-          <a:blip r:embed="rId10"/>
+          <a:blip r:embed="rId17">
+            <a:extLst>
+              <a:ext uri="{96DAC541-7B7A-43D3-8B79-37D633B846F1}">
+                <asvg:svgBlip xmlns:asvg="http://schemas.microsoft.com/office/drawing/2016/SVG/main" r:embed="rId18"/>
+              </a:ext>
+            </a:extLst>
+          </a:blip>
           <a:stretch>
             <a:fillRect/>
           </a:stretch>
@@ -32867,14 +33065,20 @@
       </p:sp>
       <p:pic>
         <p:nvPicPr>
-          <p:cNvPr id="8" name="Imagen 8" descr="heart"/>
+          <p:cNvPr id="8" name="Icono heart 8" descr="heart"/>
           <p:cNvPicPr>
             <a:picLocks noChangeAspect="1"/>
           </p:cNvPicPr>
           <p:nvPr/>
         </p:nvPicPr>
         <p:blipFill>
-          <a:blip r:embed="rId3"/>
+          <a:blip r:embed="rId3">
+            <a:extLst>
+              <a:ext uri="{96DAC541-7B7A-43D3-8B79-37D633B846F1}">
+                <asvg:svgBlip xmlns:asvg="http://schemas.microsoft.com/office/drawing/2016/SVG/main" r:embed="rId4"/>
+              </a:ext>
+            </a:extLst>
+          </a:blip>
           <a:stretch>
             <a:fillRect/>
           </a:stretch>
@@ -33055,14 +33259,20 @@
       </p:sp>
       <p:pic>
         <p:nvPicPr>
-          <p:cNvPr id="12" name="Imagen 12" descr="heart"/>
+          <p:cNvPr id="12" name="Icono heart 12" descr="heart"/>
           <p:cNvPicPr>
             <a:picLocks noChangeAspect="1"/>
           </p:cNvPicPr>
           <p:nvPr/>
         </p:nvPicPr>
         <p:blipFill>
-          <a:blip r:embed="rId3"/>
+          <a:blip r:embed="rId3">
+            <a:extLst>
+              <a:ext uri="{96DAC541-7B7A-43D3-8B79-37D633B846F1}">
+                <asvg:svgBlip xmlns:asvg="http://schemas.microsoft.com/office/drawing/2016/SVG/main" r:embed="rId4"/>
+              </a:ext>
+            </a:extLst>
+          </a:blip>
           <a:stretch>
             <a:fillRect/>
           </a:stretch>
@@ -33243,14 +33453,20 @@
       </p:sp>
       <p:pic>
         <p:nvPicPr>
-          <p:cNvPr id="16" name="Imagen 16" descr="heart"/>
+          <p:cNvPr id="16" name="Icono heart 16" descr="heart"/>
           <p:cNvPicPr>
             <a:picLocks noChangeAspect="1"/>
           </p:cNvPicPr>
           <p:nvPr/>
         </p:nvPicPr>
         <p:blipFill>
-          <a:blip r:embed="rId3"/>
+          <a:blip r:embed="rId3">
+            <a:extLst>
+              <a:ext uri="{96DAC541-7B7A-43D3-8B79-37D633B846F1}">
+                <asvg:svgBlip xmlns:asvg="http://schemas.microsoft.com/office/drawing/2016/SVG/main" r:embed="rId4"/>
+              </a:ext>
+            </a:extLst>
+          </a:blip>
           <a:stretch>
             <a:fillRect/>
           </a:stretch>
@@ -33431,14 +33647,20 @@
       </p:sp>
       <p:pic>
         <p:nvPicPr>
-          <p:cNvPr id="20" name="Imagen 20" descr="check"/>
+          <p:cNvPr id="20" name="Icono check 20" descr="check"/>
           <p:cNvPicPr>
             <a:picLocks noChangeAspect="1"/>
           </p:cNvPicPr>
           <p:nvPr/>
         </p:nvPicPr>
         <p:blipFill>
-          <a:blip r:embed="rId4"/>
+          <a:blip r:embed="rId5">
+            <a:extLst>
+              <a:ext uri="{96DAC541-7B7A-43D3-8B79-37D633B846F1}">
+                <asvg:svgBlip xmlns:asvg="http://schemas.microsoft.com/office/drawing/2016/SVG/main" r:embed="rId6"/>
+              </a:ext>
+            </a:extLst>
+          </a:blip>
           <a:stretch>
             <a:fillRect/>
           </a:stretch>
@@ -33750,14 +33972,20 @@
       </p:sp>
       <p:pic>
         <p:nvPicPr>
-          <p:cNvPr id="25" name="Imagen 25" descr="xmark"/>
+          <p:cNvPr id="25" name="Icono xmark 25" descr="xmark"/>
           <p:cNvPicPr>
             <a:picLocks noChangeAspect="1"/>
           </p:cNvPicPr>
           <p:nvPr/>
         </p:nvPicPr>
         <p:blipFill>
-          <a:blip r:embed="rId5"/>
+          <a:blip r:embed="rId7">
+            <a:extLst>
+              <a:ext uri="{96DAC541-7B7A-43D3-8B79-37D633B846F1}">
+                <asvg:svgBlip xmlns:asvg="http://schemas.microsoft.com/office/drawing/2016/SVG/main" r:embed="rId8"/>
+              </a:ext>
+            </a:extLst>
+          </a:blip>
           <a:stretch>
             <a:fillRect/>
           </a:stretch>
@@ -34168,14 +34396,20 @@
       </p:sp>
       <p:pic>
         <p:nvPicPr>
-          <p:cNvPr id="8" name="Imagen 8" descr="layers"/>
+          <p:cNvPr id="8" name="Icono layers 8" descr="layers"/>
           <p:cNvPicPr>
             <a:picLocks noChangeAspect="1"/>
           </p:cNvPicPr>
           <p:nvPr/>
         </p:nvPicPr>
         <p:blipFill>
-          <a:blip r:embed="rId3"/>
+          <a:blip r:embed="rId3">
+            <a:extLst>
+              <a:ext uri="{96DAC541-7B7A-43D3-8B79-37D633B846F1}">
+                <asvg:svgBlip xmlns:asvg="http://schemas.microsoft.com/office/drawing/2016/SVG/main" r:embed="rId4"/>
+              </a:ext>
+            </a:extLst>
+          </a:blip>
           <a:stretch>
             <a:fillRect/>
           </a:stretch>
@@ -34358,14 +34592,20 @@
       </p:sp>
       <p:pic>
         <p:nvPicPr>
-          <p:cNvPr id="12" name="Imagen 12" descr="location"/>
+          <p:cNvPr id="12" name="Icono location 12" descr="location"/>
           <p:cNvPicPr>
             <a:picLocks noChangeAspect="1"/>
           </p:cNvPicPr>
           <p:nvPr/>
         </p:nvPicPr>
         <p:blipFill>
-          <a:blip r:embed="rId4"/>
+          <a:blip r:embed="rId5">
+            <a:extLst>
+              <a:ext uri="{96DAC541-7B7A-43D3-8B79-37D633B846F1}">
+                <asvg:svgBlip xmlns:asvg="http://schemas.microsoft.com/office/drawing/2016/SVG/main" r:embed="rId6"/>
+              </a:ext>
+            </a:extLst>
+          </a:blip>
           <a:stretch>
             <a:fillRect/>
           </a:stretch>
@@ -34546,14 +34786,20 @@
       </p:sp>
       <p:pic>
         <p:nvPicPr>
-          <p:cNvPr id="16" name="Imagen 16" descr="calendar"/>
+          <p:cNvPr id="16" name="Icono calendar 16" descr="calendar"/>
           <p:cNvPicPr>
             <a:picLocks noChangeAspect="1"/>
           </p:cNvPicPr>
           <p:nvPr/>
         </p:nvPicPr>
         <p:blipFill>
-          <a:blip r:embed="rId5"/>
+          <a:blip r:embed="rId7">
+            <a:extLst>
+              <a:ext uri="{96DAC541-7B7A-43D3-8B79-37D633B846F1}">
+                <asvg:svgBlip xmlns:asvg="http://schemas.microsoft.com/office/drawing/2016/SVG/main" r:embed="rId8"/>
+              </a:ext>
+            </a:extLst>
+          </a:blip>
           <a:stretch>
             <a:fillRect/>
           </a:stretch>
@@ -34736,14 +34982,20 @@
       </p:sp>
       <p:pic>
         <p:nvPicPr>
-          <p:cNvPr id="20" name="Imagen 20" descr="users"/>
+          <p:cNvPr id="20" name="Icono users 20" descr="users"/>
           <p:cNvPicPr>
             <a:picLocks noChangeAspect="1"/>
           </p:cNvPicPr>
           <p:nvPr/>
         </p:nvPicPr>
         <p:blipFill>
-          <a:blip r:embed="rId6"/>
+          <a:blip r:embed="rId9">
+            <a:extLst>
+              <a:ext uri="{96DAC541-7B7A-43D3-8B79-37D633B846F1}">
+                <asvg:svgBlip xmlns:asvg="http://schemas.microsoft.com/office/drawing/2016/SVG/main" r:embed="rId10"/>
+              </a:ext>
+            </a:extLst>
+          </a:blip>
           <a:stretch>
             <a:fillRect/>
           </a:stretch>
@@ -34924,14 +35176,20 @@
       </p:sp>
       <p:pic>
         <p:nvPicPr>
-          <p:cNvPr id="24" name="Imagen 24" descr="filter"/>
+          <p:cNvPr id="24" name="Icono filter 24" descr="filter"/>
           <p:cNvPicPr>
             <a:picLocks noChangeAspect="1"/>
           </p:cNvPicPr>
           <p:nvPr/>
         </p:nvPicPr>
         <p:blipFill>
-          <a:blip r:embed="rId7"/>
+          <a:blip r:embed="rId11">
+            <a:extLst>
+              <a:ext uri="{96DAC541-7B7A-43D3-8B79-37D633B846F1}">
+                <asvg:svgBlip xmlns:asvg="http://schemas.microsoft.com/office/drawing/2016/SVG/main" r:embed="rId12"/>
+              </a:ext>
+            </a:extLst>
+          </a:blip>
           <a:stretch>
             <a:fillRect/>
           </a:stretch>
@@ -36426,14 +36684,20 @@
       </p:sp>
       <p:pic>
         <p:nvPicPr>
-          <p:cNvPr id="29" name="Imagen 29" descr="warn"/>
+          <p:cNvPr id="29" name="Icono warn 29" descr="warn"/>
           <p:cNvPicPr>
             <a:picLocks noChangeAspect="1"/>
           </p:cNvPicPr>
           <p:nvPr/>
         </p:nvPicPr>
         <p:blipFill>
-          <a:blip r:embed="rId8"/>
+          <a:blip r:embed="rId13">
+            <a:extLst>
+              <a:ext uri="{96DAC541-7B7A-43D3-8B79-37D633B846F1}">
+                <asvg:svgBlip xmlns:asvg="http://schemas.microsoft.com/office/drawing/2016/SVG/main" r:embed="rId14"/>
+              </a:ext>
+            </a:extLst>
+          </a:blip>
           <a:stretch>
             <a:fillRect/>
           </a:stretch>
@@ -36672,14 +36936,20 @@
       </p:sp>
       <p:pic>
         <p:nvPicPr>
-          <p:cNvPr id="7" name="Imagen 7" descr="bullseye"/>
+          <p:cNvPr id="7" name="Icono bullseye 7" descr="bullseye"/>
           <p:cNvPicPr>
             <a:picLocks noChangeAspect="1"/>
           </p:cNvPicPr>
           <p:nvPr/>
         </p:nvPicPr>
         <p:blipFill>
-          <a:blip r:embed="rId3"/>
+          <a:blip r:embed="rId3">
+            <a:extLst>
+              <a:ext uri="{96DAC541-7B7A-43D3-8B79-37D633B846F1}">
+                <asvg:svgBlip xmlns:asvg="http://schemas.microsoft.com/office/drawing/2016/SVG/main" r:embed="rId4"/>
+              </a:ext>
+            </a:extLst>
+          </a:blip>
           <a:stretch>
             <a:fillRect/>
           </a:stretch>
@@ -36957,14 +37227,20 @@
       </p:sp>
       <p:pic>
         <p:nvPicPr>
-          <p:cNvPr id="14" name="Imagen 14" descr="users"/>
+          <p:cNvPr id="14" name="Icono users 14" descr="users"/>
           <p:cNvPicPr>
             <a:picLocks noChangeAspect="1"/>
           </p:cNvPicPr>
           <p:nvPr/>
         </p:nvPicPr>
         <p:blipFill>
-          <a:blip r:embed="rId4"/>
+          <a:blip r:embed="rId5">
+            <a:extLst>
+              <a:ext uri="{96DAC541-7B7A-43D3-8B79-37D633B846F1}">
+                <asvg:svgBlip xmlns:asvg="http://schemas.microsoft.com/office/drawing/2016/SVG/main" r:embed="rId6"/>
+              </a:ext>
+            </a:extLst>
+          </a:blip>
           <a:stretch>
             <a:fillRect/>
           </a:stretch>
@@ -37180,14 +37456,20 @@
       </p:sp>
       <p:pic>
         <p:nvPicPr>
-          <p:cNvPr id="19" name="Imagen 19" descr="handmed"/>
+          <p:cNvPr id="19" name="Icono handmed 19" descr="handmed"/>
           <p:cNvPicPr>
             <a:picLocks noChangeAspect="1"/>
           </p:cNvPicPr>
           <p:nvPr/>
         </p:nvPicPr>
         <p:blipFill>
-          <a:blip r:embed="rId5"/>
+          <a:blip r:embed="rId7">
+            <a:extLst>
+              <a:ext uri="{96DAC541-7B7A-43D3-8B79-37D633B846F1}">
+                <asvg:svgBlip xmlns:asvg="http://schemas.microsoft.com/office/drawing/2016/SVG/main" r:embed="rId8"/>
+              </a:ext>
+            </a:extLst>
+          </a:blip>
           <a:stretch>
             <a:fillRect/>
           </a:stretch>
@@ -37401,14 +37683,20 @@
       </p:sp>
       <p:pic>
         <p:nvPicPr>
-          <p:cNvPr id="24" name="Imagen 24" descr="droplet"/>
+          <p:cNvPr id="24" name="Icono droplet 24" descr="droplet"/>
           <p:cNvPicPr>
             <a:picLocks noChangeAspect="1"/>
           </p:cNvPicPr>
           <p:nvPr/>
         </p:nvPicPr>
         <p:blipFill>
-          <a:blip r:embed="rId6"/>
+          <a:blip r:embed="rId9">
+            <a:extLst>
+              <a:ext uri="{96DAC541-7B7A-43D3-8B79-37D633B846F1}">
+                <asvg:svgBlip xmlns:asvg="http://schemas.microsoft.com/office/drawing/2016/SVG/main" r:embed="rId10"/>
+              </a:ext>
+            </a:extLst>
+          </a:blip>
           <a:stretch>
             <a:fillRect/>
           </a:stretch>
@@ -37624,14 +37912,20 @@
       </p:sp>
       <p:pic>
         <p:nvPicPr>
-          <p:cNvPr id="29" name="Imagen 29" descr="chart"/>
+          <p:cNvPr id="29" name="Icono chart 29" descr="chart"/>
           <p:cNvPicPr>
             <a:picLocks noChangeAspect="1"/>
           </p:cNvPicPr>
           <p:nvPr/>
         </p:nvPicPr>
         <p:blipFill>
-          <a:blip r:embed="rId7"/>
+          <a:blip r:embed="rId11">
+            <a:extLst>
+              <a:ext uri="{96DAC541-7B7A-43D3-8B79-37D633B846F1}">
+                <asvg:svgBlip xmlns:asvg="http://schemas.microsoft.com/office/drawing/2016/SVG/main" r:embed="rId12"/>
+              </a:ext>
+            </a:extLst>
+          </a:blip>
           <a:stretch>
             <a:fillRect/>
           </a:stretch>
@@ -37845,14 +38139,20 @@
       </p:sp>
       <p:pic>
         <p:nvPicPr>
-          <p:cNvPr id="34" name="Imagen 34" descr="search"/>
+          <p:cNvPr id="34" name="Icono search 34" descr="search"/>
           <p:cNvPicPr>
             <a:picLocks noChangeAspect="1"/>
           </p:cNvPicPr>
           <p:nvPr/>
         </p:nvPicPr>
         <p:blipFill>
-          <a:blip r:embed="rId8"/>
+          <a:blip r:embed="rId13">
+            <a:extLst>
+              <a:ext uri="{96DAC541-7B7A-43D3-8B79-37D633B846F1}">
+                <asvg:svgBlip xmlns:asvg="http://schemas.microsoft.com/office/drawing/2016/SVG/main" r:embed="rId14"/>
+              </a:ext>
+            </a:extLst>
+          </a:blip>
           <a:stretch>
             <a:fillRect/>
           </a:stretch>
@@ -40665,14 +40965,20 @@
       </p:sp>
       <p:pic>
         <p:nvPicPr>
-          <p:cNvPr id="9" name="Imagen 9" descr="clipboard"/>
+          <p:cNvPr id="9" name="Icono clipboard 9" descr="clipboard"/>
           <p:cNvPicPr>
             <a:picLocks noChangeAspect="1"/>
           </p:cNvPicPr>
           <p:nvPr/>
         </p:nvPicPr>
         <p:blipFill>
-          <a:blip r:embed="rId3"/>
+          <a:blip r:embed="rId3">
+            <a:extLst>
+              <a:ext uri="{96DAC541-7B7A-43D3-8B79-37D633B846F1}">
+                <asvg:svgBlip xmlns:asvg="http://schemas.microsoft.com/office/drawing/2016/SVG/main" r:embed="rId4"/>
+              </a:ext>
+            </a:extLst>
+          </a:blip>
           <a:stretch>
             <a:fillRect/>
           </a:stretch>
@@ -40975,14 +41281,20 @@
       </p:sp>
       <p:pic>
         <p:nvPicPr>
-          <p:cNvPr id="16" name="Imagen 16" descr="heartpulse"/>
+          <p:cNvPr id="16" name="Icono heartpulse 16" descr="heartpulse"/>
           <p:cNvPicPr>
             <a:picLocks noChangeAspect="1"/>
           </p:cNvPicPr>
           <p:nvPr/>
         </p:nvPicPr>
         <p:blipFill>
-          <a:blip r:embed="rId4"/>
+          <a:blip r:embed="rId5">
+            <a:extLst>
+              <a:ext uri="{96DAC541-7B7A-43D3-8B79-37D633B846F1}">
+                <asvg:svgBlip xmlns:asvg="http://schemas.microsoft.com/office/drawing/2016/SVG/main" r:embed="rId6"/>
+              </a:ext>
+            </a:extLst>
+          </a:blip>
           <a:stretch>
             <a:fillRect/>
           </a:stretch>
@@ -41285,14 +41597,20 @@
       </p:sp>
       <p:pic>
         <p:nvPicPr>
-          <p:cNvPr id="23" name="Imagen 23" descr="bed"/>
+          <p:cNvPr id="23" name="Icono bed 23" descr="bed"/>
           <p:cNvPicPr>
             <a:picLocks noChangeAspect="1"/>
           </p:cNvPicPr>
           <p:nvPr/>
         </p:nvPicPr>
         <p:blipFill>
-          <a:blip r:embed="rId5"/>
+          <a:blip r:embed="rId7">
+            <a:extLst>
+              <a:ext uri="{96DAC541-7B7A-43D3-8B79-37D633B846F1}">
+                <asvg:svgBlip xmlns:asvg="http://schemas.microsoft.com/office/drawing/2016/SVG/main" r:embed="rId8"/>
+              </a:ext>
+            </a:extLst>
+          </a:blip>
           <a:stretch>
             <a:fillRect/>
           </a:stretch>
@@ -42051,14 +42369,20 @@
       </p:sp>
       <p:pic>
         <p:nvPicPr>
-          <p:cNvPr id="7" name="Imagen 7" descr="chart"/>
+          <p:cNvPr id="7" name="Icono chart 7" descr="chart"/>
           <p:cNvPicPr>
             <a:picLocks noChangeAspect="1"/>
           </p:cNvPicPr>
           <p:nvPr/>
         </p:nvPicPr>
         <p:blipFill>
-          <a:blip r:embed="rId3"/>
+          <a:blip r:embed="rId3">
+            <a:extLst>
+              <a:ext uri="{96DAC541-7B7A-43D3-8B79-37D633B846F1}">
+                <asvg:svgBlip xmlns:asvg="http://schemas.microsoft.com/office/drawing/2016/SVG/main" r:embed="rId4"/>
+              </a:ext>
+            </a:extLst>
+          </a:blip>
           <a:stretch>
             <a:fillRect/>
           </a:stretch>
@@ -42276,14 +42600,20 @@
       </p:sp>
       <p:pic>
         <p:nvPicPr>
-          <p:cNvPr id="12" name="Imagen 12" descr="bulb"/>
+          <p:cNvPr id="12" name="Icono bulb 12" descr="bulb"/>
           <p:cNvPicPr>
             <a:picLocks noChangeAspect="1"/>
           </p:cNvPicPr>
           <p:nvPr/>
         </p:nvPicPr>
         <p:blipFill>
-          <a:blip r:embed="rId4"/>
+          <a:blip r:embed="rId5">
+            <a:extLst>
+              <a:ext uri="{96DAC541-7B7A-43D3-8B79-37D633B846F1}">
+                <asvg:svgBlip xmlns:asvg="http://schemas.microsoft.com/office/drawing/2016/SVG/main" r:embed="rId6"/>
+              </a:ext>
+            </a:extLst>
+          </a:blip>
           <a:stretch>
             <a:fillRect/>
           </a:stretch>
@@ -42517,14 +42847,20 @@
       </p:sp>
       <p:pic>
         <p:nvPicPr>
-          <p:cNvPr id="17" name="Imagen 17" descr="handmed"/>
+          <p:cNvPr id="17" name="Icono handmed 17" descr="handmed"/>
           <p:cNvPicPr>
             <a:picLocks noChangeAspect="1"/>
           </p:cNvPicPr>
           <p:nvPr/>
         </p:nvPicPr>
         <p:blipFill>
-          <a:blip r:embed="rId5"/>
+          <a:blip r:embed="rId7">
+            <a:extLst>
+              <a:ext uri="{96DAC541-7B7A-43D3-8B79-37D633B846F1}">
+                <asvg:svgBlip xmlns:asvg="http://schemas.microsoft.com/office/drawing/2016/SVG/main" r:embed="rId8"/>
+              </a:ext>
+            </a:extLst>
+          </a:blip>
           <a:stretch>
             <a:fillRect/>
           </a:stretch>
@@ -42759,14 +43095,20 @@
       </p:sp>
       <p:pic>
         <p:nvPicPr>
-          <p:cNvPr id="22" name="Imagen 22" descr="database"/>
+          <p:cNvPr id="22" name="Icono database 22" descr="database"/>
           <p:cNvPicPr>
             <a:picLocks noChangeAspect="1"/>
           </p:cNvPicPr>
           <p:nvPr/>
         </p:nvPicPr>
         <p:blipFill>
-          <a:blip r:embed="rId6"/>
+          <a:blip r:embed="rId9">
+            <a:extLst>
+              <a:ext uri="{96DAC541-7B7A-43D3-8B79-37D633B846F1}">
+                <asvg:svgBlip xmlns:asvg="http://schemas.microsoft.com/office/drawing/2016/SVG/main" r:embed="rId10"/>
+              </a:ext>
+            </a:extLst>
+          </a:blip>
           <a:stretch>
             <a:fillRect/>
           </a:stretch>
@@ -43279,14 +43621,20 @@
       </p:sp>
       <p:pic>
         <p:nvPicPr>
-          <p:cNvPr id="7" name="Imagen 7" descr="filemed"/>
+          <p:cNvPr id="7" name="Icono filemed 7" descr="filemed"/>
           <p:cNvPicPr>
             <a:picLocks noChangeAspect="1"/>
           </p:cNvPicPr>
           <p:nvPr/>
         </p:nvPicPr>
         <p:blipFill>
-          <a:blip r:embed="rId3"/>
+          <a:blip r:embed="rId3">
+            <a:extLst>
+              <a:ext uri="{96DAC541-7B7A-43D3-8B79-37D633B846F1}">
+                <asvg:svgBlip xmlns:asvg="http://schemas.microsoft.com/office/drawing/2016/SVG/main" r:embed="rId4"/>
+              </a:ext>
+            </a:extLst>
+          </a:blip>
           <a:stretch>
             <a:fillRect/>
           </a:stretch>
@@ -43501,14 +43849,20 @@
       </p:sp>
       <p:pic>
         <p:nvPicPr>
-          <p:cNvPr id="12" name="Imagen 12" descr="globe"/>
+          <p:cNvPr id="12" name="Icono globe 12" descr="globe"/>
           <p:cNvPicPr>
             <a:picLocks noChangeAspect="1"/>
           </p:cNvPicPr>
           <p:nvPr/>
         </p:nvPicPr>
         <p:blipFill>
-          <a:blip r:embed="rId4"/>
+          <a:blip r:embed="rId5">
+            <a:extLst>
+              <a:ext uri="{96DAC541-7B7A-43D3-8B79-37D633B846F1}">
+                <asvg:svgBlip xmlns:asvg="http://schemas.microsoft.com/office/drawing/2016/SVG/main" r:embed="rId6"/>
+              </a:ext>
+            </a:extLst>
+          </a:blip>
           <a:stretch>
             <a:fillRect/>
           </a:stretch>
@@ -43723,14 +44077,20 @@
       </p:sp>
       <p:pic>
         <p:nvPicPr>
-          <p:cNvPr id="17" name="Imagen 17" descr="hospital"/>
+          <p:cNvPr id="17" name="Icono hospital 17" descr="hospital"/>
           <p:cNvPicPr>
             <a:picLocks noChangeAspect="1"/>
           </p:cNvPicPr>
           <p:nvPr/>
         </p:nvPicPr>
         <p:blipFill>
-          <a:blip r:embed="rId5"/>
+          <a:blip r:embed="rId7">
+            <a:extLst>
+              <a:ext uri="{96DAC541-7B7A-43D3-8B79-37D633B846F1}">
+                <asvg:svgBlip xmlns:asvg="http://schemas.microsoft.com/office/drawing/2016/SVG/main" r:embed="rId8"/>
+              </a:ext>
+            </a:extLst>
+          </a:blip>
           <a:stretch>
             <a:fillRect/>
           </a:stretch>
@@ -43944,14 +44304,20 @@
       </p:sp>
       <p:pic>
         <p:nvPicPr>
-          <p:cNvPr id="22" name="Imagen 22" descr="question"/>
+          <p:cNvPr id="22" name="Icono question 22" descr="question"/>
           <p:cNvPicPr>
             <a:picLocks noChangeAspect="1"/>
           </p:cNvPicPr>
           <p:nvPr/>
         </p:nvPicPr>
         <p:blipFill>
-          <a:blip r:embed="rId6"/>
+          <a:blip r:embed="rId9">
+            <a:extLst>
+              <a:ext uri="{96DAC541-7B7A-43D3-8B79-37D633B846F1}">
+                <asvg:svgBlip xmlns:asvg="http://schemas.microsoft.com/office/drawing/2016/SVG/main" r:embed="rId10"/>
+              </a:ext>
+            </a:extLst>
+          </a:blip>
           <a:stretch>
             <a:fillRect/>
           </a:stretch>
@@ -44542,14 +44908,20 @@
       </p:sp>
       <p:pic>
         <p:nvPicPr>
-          <p:cNvPr id="7" name="Imagen 7" descr="scale"/>
+          <p:cNvPr id="7" name="Icono scale 7" descr="scale"/>
           <p:cNvPicPr>
             <a:picLocks noChangeAspect="1"/>
           </p:cNvPicPr>
           <p:nvPr/>
         </p:nvPicPr>
         <p:blipFill>
-          <a:blip r:embed="rId3"/>
+          <a:blip r:embed="rId3">
+            <a:extLst>
+              <a:ext uri="{96DAC541-7B7A-43D3-8B79-37D633B846F1}">
+                <asvg:svgBlip xmlns:asvg="http://schemas.microsoft.com/office/drawing/2016/SVG/main" r:embed="rId4"/>
+              </a:ext>
+            </a:extLst>
+          </a:blip>
           <a:stretch>
             <a:fillRect/>
           </a:stretch>
@@ -45372,14 +45744,20 @@
       </p:sp>
       <p:pic>
         <p:nvPicPr>
-          <p:cNvPr id="21" name="Imagen 21" descr="warn"/>
+          <p:cNvPr id="21" name="Icono warn 21" descr="warn"/>
           <p:cNvPicPr>
             <a:picLocks noChangeAspect="1"/>
           </p:cNvPicPr>
           <p:nvPr/>
         </p:nvPicPr>
         <p:blipFill>
-          <a:blip r:embed="rId4"/>
+          <a:blip r:embed="rId5">
+            <a:extLst>
+              <a:ext uri="{96DAC541-7B7A-43D3-8B79-37D633B846F1}">
+                <asvg:svgBlip xmlns:asvg="http://schemas.microsoft.com/office/drawing/2016/SVG/main" r:embed="rId6"/>
+              </a:ext>
+            </a:extLst>
+          </a:blip>
           <a:stretch>
             <a:fillRect/>
           </a:stretch>
@@ -45556,14 +45934,20 @@
       </p:sp>
       <p:pic>
         <p:nvPicPr>
-          <p:cNvPr id="25" name="Imagen 25" descr="heartcrack"/>
+          <p:cNvPr id="25" name="Icono heartcrack 25" descr="heartcrack"/>
           <p:cNvPicPr>
             <a:picLocks noChangeAspect="1"/>
           </p:cNvPicPr>
           <p:nvPr/>
         </p:nvPicPr>
         <p:blipFill>
-          <a:blip r:embed="rId5"/>
+          <a:blip r:embed="rId7">
+            <a:extLst>
+              <a:ext uri="{96DAC541-7B7A-43D3-8B79-37D633B846F1}">
+                <asvg:svgBlip xmlns:asvg="http://schemas.microsoft.com/office/drawing/2016/SVG/main" r:embed="rId8"/>
+              </a:ext>
+            </a:extLst>
+          </a:blip>
           <a:stretch>
             <a:fillRect/>
           </a:stretch>
@@ -46434,14 +46818,20 @@
       </p:sp>
       <p:pic>
         <p:nvPicPr>
-          <p:cNvPr id="7" name="Imagen 7" descr="heartpulse"/>
+          <p:cNvPr id="7" name="Icono heartpulse 7" descr="heartpulse"/>
           <p:cNvPicPr>
             <a:picLocks noChangeAspect="1"/>
           </p:cNvPicPr>
           <p:nvPr/>
         </p:nvPicPr>
         <p:blipFill>
-          <a:blip r:embed="rId3"/>
+          <a:blip r:embed="rId3">
+            <a:extLst>
+              <a:ext uri="{96DAC541-7B7A-43D3-8B79-37D633B846F1}">
+                <asvg:svgBlip xmlns:asvg="http://schemas.microsoft.com/office/drawing/2016/SVG/main" r:embed="rId4"/>
+              </a:ext>
+            </a:extLst>
+          </a:blip>
           <a:stretch>
             <a:fillRect/>
           </a:stretch>
@@ -46630,14 +47020,20 @@
       </p:sp>
       <p:pic>
         <p:nvPicPr>
-          <p:cNvPr id="11" name="Imagen 11" descr="dropslash"/>
+          <p:cNvPr id="11" name="Icono dropslash 11" descr="dropslash"/>
           <p:cNvPicPr>
             <a:picLocks noChangeAspect="1"/>
           </p:cNvPicPr>
           <p:nvPr/>
         </p:nvPicPr>
         <p:blipFill>
-          <a:blip r:embed="rId4"/>
+          <a:blip r:embed="rId5">
+            <a:extLst>
+              <a:ext uri="{96DAC541-7B7A-43D3-8B79-37D633B846F1}">
+                <asvg:svgBlip xmlns:asvg="http://schemas.microsoft.com/office/drawing/2016/SVG/main" r:embed="rId6"/>
+              </a:ext>
+            </a:extLst>
+          </a:blip>
           <a:stretch>
             <a:fillRect/>
           </a:stretch>
@@ -47285,14 +47681,20 @@
       </p:sp>
       <p:pic>
         <p:nvPicPr>
-          <p:cNvPr id="24" name="Imagen 24" descr="warn"/>
+          <p:cNvPr id="24" name="Icono warn 24" descr="warn"/>
           <p:cNvPicPr>
             <a:picLocks noChangeAspect="1"/>
           </p:cNvPicPr>
           <p:nvPr/>
         </p:nvPicPr>
         <p:blipFill>
-          <a:blip r:embed="rId5"/>
+          <a:blip r:embed="rId7">
+            <a:extLst>
+              <a:ext uri="{96DAC541-7B7A-43D3-8B79-37D633B846F1}">
+                <asvg:svgBlip xmlns:asvg="http://schemas.microsoft.com/office/drawing/2016/SVG/main" r:embed="rId8"/>
+              </a:ext>
+            </a:extLst>
+          </a:blip>
           <a:stretch>
             <a:fillRect/>
           </a:stretch>

</xml_diff>